<commit_message>
Add voice-method handout; reframe RTCF for frontier vs self-hosted models
Voice method: new companion-site handout "Make your edge persistent: the
two-page voice method" (Ethan Mollick), framed as the persistent version of
the two-pass demo's edge-injection, linking to Style Mirror
(stylemirror.eduserver.au) which can run locally. Section added to the
Frameworks page; facilitator pointer in the two-pass demo notes.

RTCF: make explicit that Role/Task/Format are scaffolding (most valuable on
weaker/self-hosted models; frontier models infer them from clear writing),
while Context is the part that always matters — the one thing only you supply.
Lands on the RTCF slide (visible beat + notes) and the prompt-library worksheet.
Chatbot knowledge refreshed (22 docs).
</commit_message>
<xml_diff>
--- a/content/slide-deck.pptx
+++ b/content/slide-deck.pptx
@@ -1258,19 +1258,71 @@
             <a:pPr lvl="0"/>
             <a:r>
               <a:rPr/>
-              <a:t>Not every prompt needs all four. But for anything important, all four transform the result.</a:t>
-            </a:r>
-          </a:p>
-          <a:p>
-            <a:pPr lvl="0" indent="0" marL="0">
-              <a:buNone/>
-            </a:pPr>
-          </a:p>
-          <a:p>
-            <a:pPr lvl="0"/>
-            <a:r>
-              <a:rPr/>
-              <a:t>RTCF isn’t a trick — it’s just being clear about what you actually want, which is the skill underneath all good prompting.</a:t>
+              <a:t>Separate the two halves of RTCF:</a:t>
+            </a:r>
+          </a:p>
+          <a:p>
+            <a:pPr lvl="0" indent="0" marL="0">
+              <a:buNone/>
+            </a:pPr>
+          </a:p>
+          <a:p>
+            <a:pPr lvl="1"/>
+            <a:r>
+              <a:rPr b="1"/>
+              <a:t>Scaffolding (Role, Task, Format):</a:t>
+            </a:r>
+            <a:r>
+              <a:rPr/>
+              <a:t> mostly for weaker / self-hosted models that need the structure. A frontier model (Claude, GPT-4-class) follows plain, well-written instructions well — if you’re good at briefing a human, you’re most of the way there. Use the labels as a checklist, not a rigid template you must fill every time. Over-ritualising them can even make prompts worse.</a:t>
+            </a:r>
+          </a:p>
+          <a:p>
+            <a:pPr lvl="0" indent="0" marL="0">
+              <a:buNone/>
+            </a:pPr>
+          </a:p>
+          <a:p>
+            <a:pPr lvl="1"/>
+            <a:r>
+              <a:rPr b="1"/>
+              <a:t>Context:</a:t>
+            </a:r>
+            <a:r>
+              <a:rPr/>
+              <a:t> the one part that matters on </a:t>
+            </a:r>
+            <a:r>
+              <a:rPr i="1"/>
+              <a:t>any</a:t>
+            </a:r>
+            <a:r>
+              <a:rPr/>
+              <a:t> model, because it’s the thing only you hold — your specifics, your edge. No model, however smart, can manufacture your context.</a:t>
+            </a:r>
+          </a:p>
+          <a:p>
+            <a:pPr lvl="0" indent="0" marL="0">
+              <a:buNone/>
+            </a:pPr>
+          </a:p>
+          <a:p>
+            <a:pPr lvl="0"/>
+            <a:r>
+              <a:rPr/>
+              <a:t>So the durable skill isn’t “master a prompt framework.” It’s the skill that already makes you good at instructing people: being clear about what you want, and supplying the context the receiver can’t infer. RTCF just names the parts — and as models get smarter, the scaffolding fades, leaving exactly your judgement and context.</a:t>
+            </a:r>
+          </a:p>
+          <a:p>
+            <a:pPr lvl="0" indent="0" marL="0">
+              <a:buNone/>
+            </a:pPr>
+          </a:p>
+          <a:p>
+            <a:pPr lvl="0"/>
+            <a:r>
+              <a:rPr/>
+              <a:t>Honest note for the self-hosted crowd: if you run smaller local models (Ollama etc.), RTCF’s full structure earns its keep — that’s where it pays off most.</a:t>
             </a:r>
           </a:p>
         </p:txBody>
@@ -1535,6 +1587,18 @@
             <a:r>
               <a:rPr/>
               <a:t>.</a:t>
+            </a:r>
+          </a:p>
+          <a:p>
+            <a:pPr lvl="0" indent="0" marL="0">
+              <a:buNone/>
+            </a:pPr>
+          </a:p>
+          <a:p>
+            <a:pPr lvl="0"/>
+            <a:r>
+              <a:rPr/>
+              <a:t>Go deeper (companion site): the “two-page voice method” makes this edge persistent — give the AI a writing sample, have it produce a style brief, paste it into custom instructions. Free tool: Style Mirror (stylemirror.eduserver.au), which can run locally. Caveat to land: the result is a “slight parody” of you — an average of your voice — so the residual edge stays yours.</a:t>
             </a:r>
           </a:p>
         </p:txBody>
@@ -8455,7 +8519,11 @@
             </a:r>
             <a:r>
               <a:rPr/>
-              <a:t> — Context (what does it need to know?)</a:t>
+              <a:t> — Context (what does it need to know?) — </a:t>
+            </a:r>
+            <a:r>
+              <a:rPr i="1"/>
+              <a:t>where your edge enters</a:t>
             </a:r>
           </a:p>
           <a:p>
@@ -8467,6 +8535,27 @@
             <a:r>
               <a:rPr/>
               <a:t> — Format (how should the output look?)</a:t>
+            </a:r>
+          </a:p>
+          <a:p>
+            <a:pPr lvl="0" indent="0" marL="0">
+              <a:buNone/>
+            </a:pPr>
+            <a:r>
+              <a:rPr b="1"/>
+              <a:t>Role, Task and Format are scaffolding</a:t>
+            </a:r>
+            <a:r>
+              <a:rPr/>
+              <a:t> — weaker or self-hosted models need it spelled out; a frontier model infers it from clear writing. </a:t>
+            </a:r>
+            <a:r>
+              <a:rPr b="1"/>
+              <a:t>Context is the part that always matters</a:t>
+            </a:r>
+            <a:r>
+              <a:rPr/>
+              <a:t> — it’s the one thing only you supply.</a:t>
             </a:r>
           </a:p>
         </p:txBody>

</xml_diff>